<commit_message>
rename: AI teammate Kai -> Arjuna across app, docs, deck, explainer
Agent display name changed everywhere (app UI, team roster, about.html landing,
walkthrough, changelog, deck, video script). Code variable kai -> arjuna. Tests
updated in lockstep (breakeven role strings); 23/23 green. Deck regenerated.

Co-Authored-By: Claude Fable 5 <noreply@anthropic.com>
</commit_message>
<xml_diff>
--- a/day_9x_stakeholder_deck.pptx
+++ b/day_9x_stakeholder_deck.pptx
@@ -3507,7 +3507,7 @@
                 </a:solidFill>
                 <a:latin typeface="Segoe UI"/>
               </a:rPr>
-              <a:t>•  In this story the AI is the junior; the humans are the mentors, reviewers and deciders. Every hour Kai returns is redeployed toward the review-and-judgement work that was always understaffed.</a:t>
+              <a:t>•  In this story the AI is the junior; the humans are the mentors, reviewers and deciders. Every hour Arjuna returns is redeployed toward the review-and-judgement work that was always understaffed.</a:t>
             </a:r>
           </a:p>
           <a:p>
@@ -3523,7 +3523,7 @@
                 </a:solidFill>
                 <a:latin typeface="Segoe UI"/>
               </a:rPr>
-              <a:t>•  Over a modelled turnaround run, Kai returns ~432 analyst-hours to named teammates — Priya (triage), Arun (recon), Sofia (DQ) — who shift from doing the routine work to reviewing and directing it.</a:t>
+              <a:t>•  Over a modelled turnaround run, Arjuna returns ~432 analyst-hours to named teammates — Priya (triage), Arun (recon), Sofia (DQ) — who shift from doing the routine work to reviewing and directing it.</a:t>
             </a:r>
           </a:p>
           <a:p>
@@ -4694,7 +4694,7 @@
                 </a:solidFill>
                 <a:latin typeface="Segoe UI"/>
               </a:rPr>
-              <a:t>•  Ask Kai: 'Can I rerun the CreditMart load on Thursday morning?'</a:t>
+              <a:t>•  Ask Arjuna: 'Can I rerun the CreditMart load on Thursday morning?'</a:t>
             </a:r>
           </a:p>
           <a:p>
@@ -4742,7 +4742,7 @@
                 </a:solidFill>
                 <a:latin typeface="Segoe UI"/>
               </a:rPr>
-              <a:t>–  After: Kai answers correctly, citing unwritten_rules.md.</a:t>
+              <a:t>–  After: Arjuna answers correctly, citing unwritten_rules.md.</a:t>
             </a:r>
           </a:p>
           <a:p>
@@ -4870,7 +4870,7 @@
                 </a:solidFill>
                 <a:latin typeface="Segoe UI"/>
               </a:rPr>
-              <a:t>The second money shot: Kai mines what the corpus can't answer</a:t>
+              <a:t>The second money shot: Arjuna mines what the corpus can't answer</a:t>
             </a:r>
           </a:p>
         </p:txBody>
@@ -4909,7 +4909,7 @@
                 </a:solidFill>
                 <a:latin typeface="Segoe UI"/>
               </a:rPr>
-              <a:t>•  When Kai can't answer, the miss isn't lost — it's logged as a structured knowledge gap (a mining lead), never a silent hallucination.</a:t>
+              <a:t>•  When Arjuna can't answer, the miss isn't lost — it's logged as a structured knowledge gap (a mining lead), never a silent hallucination.</a:t>
             </a:r>
           </a:p>
           <a:p>
@@ -4925,7 +4925,7 @@
                 </a:solidFill>
                 <a:latin typeface="Segoe UI"/>
               </a:rPr>
-              <a:t>•  Kai turns the gap into SME interview questions; the SME answers; Kai writes it up as a versioned, ATTRIBUTED Skill and reindexes — the question it abstained on now answers, with a citation.</a:t>
+              <a:t>•  Arjuna turns the gap into SME interview questions; the SME answers; Arjuna writes it up as a versioned, ATTRIBUTED Skill and reindexes — the question it abstained on now answers, with a citation.</a:t>
             </a:r>
           </a:p>
           <a:p>

</xml_diff>